<commit_message>
Se agregó estabilidad completa en modelos 2qrs, y instituto también
</commit_message>
<xml_diff>
--- a/app/templates/universidad_2qrs/plantilla_curso.pptx
+++ b/app/templates/universidad_2qrs/plantilla_curso.pptx
@@ -119,112 +119,84 @@
 </p:presentation>
 </file>
 
+<file path=ppt/revisionInfo.xml><?xml version="1.0" encoding="utf-8"?>
+<p1510:revInfo xmlns:a="http://schemas.openxmlformats.org/drawingml/2006/main" xmlns:r="http://schemas.openxmlformats.org/officeDocument/2006/relationships" xmlns:p1510="http://schemas.microsoft.com/office/powerpoint/2015/10/main">
+  <p1510:revLst>
+    <p1510:client id="{5CDB807E-DD06-483B-B80B-6C511E3BD997}" v="4" dt="2026-03-02T03:10:34.838"/>
+  </p1510:revLst>
+</p1510:revInfo>
+</file>
+
 <file path=ppt/changesInfos/changesInfo1.xml><?xml version="1.0" encoding="utf-8"?>
 <pc:chgInfo xmlns:a="http://schemas.openxmlformats.org/drawingml/2006/main" xmlns:r="http://schemas.openxmlformats.org/officeDocument/2006/relationships" xmlns:ac="http://schemas.microsoft.com/office/drawing/2013/main/command" xmlns:pc="http://schemas.microsoft.com/office/powerpoint/2013/main/command">
   <pc:docChgLst>
     <pc:chgData name="Benjamín de Jesús Cueva Niño de Guzmán" userId="56da303013910523" providerId="LiveId" clId="{532B7A48-8887-4F62-9537-0BA1FAE83637}"/>
     <pc:docChg chg="custSel delSld modSld">
-      <pc:chgData name="Benjamín de Jesús Cueva Niño de Guzmán" userId="56da303013910523" providerId="LiveId" clId="{532B7A48-8887-4F62-9537-0BA1FAE83637}" dt="2026-01-14T23:39:32.441" v="15" actId="6549"/>
+      <pc:chgData name="Benjamín de Jesús Cueva Niño de Guzmán" userId="56da303013910523" providerId="LiveId" clId="{532B7A48-8887-4F62-9537-0BA1FAE83637}" dt="2026-03-02T03:10:34.838" v="58" actId="962"/>
       <pc:docMkLst>
         <pc:docMk/>
       </pc:docMkLst>
-      <pc:sldChg chg="delSp modSp mod">
-        <pc:chgData name="Benjamín de Jesús Cueva Niño de Guzmán" userId="56da303013910523" providerId="LiveId" clId="{532B7A48-8887-4F62-9537-0BA1FAE83637}" dt="2026-01-14T23:39:12.411" v="12" actId="1036"/>
+      <pc:sldChg chg="addSp delSp modSp mod">
+        <pc:chgData name="Benjamín de Jesús Cueva Niño de Guzmán" userId="56da303013910523" providerId="LiveId" clId="{532B7A48-8887-4F62-9537-0BA1FAE83637}" dt="2026-03-02T03:10:34.838" v="58" actId="962"/>
         <pc:sldMkLst>
           <pc:docMk/>
           <pc:sldMk cId="2410626708" sldId="277"/>
         </pc:sldMkLst>
         <pc:spChg chg="mod">
-          <ac:chgData name="Benjamín de Jesús Cueva Niño de Guzmán" userId="56da303013910523" providerId="LiveId" clId="{532B7A48-8887-4F62-9537-0BA1FAE83637}" dt="2026-01-14T23:39:12.411" v="12" actId="1036"/>
+          <ac:chgData name="Benjamín de Jesús Cueva Niño de Guzmán" userId="56da303013910523" providerId="LiveId" clId="{532B7A48-8887-4F62-9537-0BA1FAE83637}" dt="2026-03-02T03:09:45.056" v="28" actId="1035"/>
           <ac:spMkLst>
             <pc:docMk/>
             <pc:sldMk cId="2410626708" sldId="277"/>
-            <ac:spMk id="22" creationId="{D6CB106F-7EC0-002A-CEBE-0064B169D038}"/>
+            <ac:spMk id="2" creationId="{6718E74D-9F2C-B892-E699-1EC198F4A308}"/>
           </ac:spMkLst>
         </pc:spChg>
         <pc:spChg chg="mod">
-          <ac:chgData name="Benjamín de Jesús Cueva Niño de Guzmán" userId="56da303013910523" providerId="LiveId" clId="{532B7A48-8887-4F62-9537-0BA1FAE83637}" dt="2026-01-14T23:39:12.411" v="12" actId="1036"/>
+          <ac:chgData name="Benjamín de Jesús Cueva Niño de Guzmán" userId="56da303013910523" providerId="LiveId" clId="{532B7A48-8887-4F62-9537-0BA1FAE83637}" dt="2026-03-02T03:10:01.503" v="51" actId="164"/>
           <ac:spMkLst>
             <pc:docMk/>
             <pc:sldMk cId="2410626708" sldId="277"/>
-            <ac:spMk id="23" creationId="{D962536F-CB9F-1938-8F28-5D8C8FE943C7}"/>
+            <ac:spMk id="7" creationId="{F36D8880-B179-580E-0319-C4E9487E072A}"/>
           </ac:spMkLst>
         </pc:spChg>
-        <pc:picChg chg="del">
-          <ac:chgData name="Benjamín de Jesús Cueva Niño de Guzmán" userId="56da303013910523" providerId="LiveId" clId="{532B7A48-8887-4F62-9537-0BA1FAE83637}" dt="2026-01-14T23:39:07" v="4" actId="478"/>
-          <ac:picMkLst>
+        <pc:spChg chg="mod">
+          <ac:chgData name="Benjamín de Jesús Cueva Niño de Guzmán" userId="56da303013910523" providerId="LiveId" clId="{532B7A48-8887-4F62-9537-0BA1FAE83637}" dt="2026-03-02T03:10:34.838" v="58" actId="962"/>
+          <ac:spMkLst>
             <pc:docMk/>
             <pc:sldMk cId="2410626708" sldId="277"/>
-            <ac:picMk id="18" creationId="{65D7DBE5-F3CD-0E62-8756-B223F377361E}"/>
-          </ac:picMkLst>
-        </pc:picChg>
+            <ac:spMk id="19" creationId="{991C4A27-894B-7257-8062-6F839343BAAD}"/>
+          </ac:spMkLst>
+        </pc:spChg>
+        <pc:grpChg chg="add mod">
+          <ac:chgData name="Benjamín de Jesús Cueva Niño de Guzmán" userId="56da303013910523" providerId="LiveId" clId="{532B7A48-8887-4F62-9537-0BA1FAE83637}" dt="2026-03-02T03:10:01.503" v="51" actId="164"/>
+          <ac:grpSpMkLst>
+            <pc:docMk/>
+            <pc:sldMk cId="2410626708" sldId="277"/>
+            <ac:grpSpMk id="10" creationId="{4ED8877D-BD75-82CF-C5B8-EF26E5F3D309}"/>
+          </ac:grpSpMkLst>
+        </pc:grpChg>
       </pc:sldChg>
-      <pc:sldChg chg="delSp modSp mod">
-        <pc:chgData name="Benjamín de Jesús Cueva Niño de Guzmán" userId="56da303013910523" providerId="LiveId" clId="{532B7A48-8887-4F62-9537-0BA1FAE83637}" dt="2026-01-14T23:39:32.441" v="15" actId="6549"/>
+      <pc:sldChg chg="modSp mod">
+        <pc:chgData name="Benjamín de Jesús Cueva Niño de Guzmán" userId="56da303013910523" providerId="LiveId" clId="{532B7A48-8887-4F62-9537-0BA1FAE83637}" dt="2026-03-02T03:10:28.186" v="57" actId="962"/>
         <pc:sldMkLst>
           <pc:docMk/>
           <pc:sldMk cId="4084903007" sldId="278"/>
         </pc:sldMkLst>
         <pc:spChg chg="mod">
-          <ac:chgData name="Benjamín de Jesús Cueva Niño de Guzmán" userId="56da303013910523" providerId="LiveId" clId="{532B7A48-8887-4F62-9537-0BA1FAE83637}" dt="2026-01-14T23:39:32.441" v="15" actId="6549"/>
+          <ac:chgData name="Benjamín de Jesús Cueva Niño de Guzmán" userId="56da303013910523" providerId="LiveId" clId="{532B7A48-8887-4F62-9537-0BA1FAE83637}" dt="2026-03-02T03:10:28.186" v="57" actId="962"/>
           <ac:spMkLst>
             <pc:docMk/>
             <pc:sldMk cId="4084903007" sldId="278"/>
-            <ac:spMk id="25" creationId="{1BD7C6F0-73B6-617B-0B21-594BAED95EBF}"/>
+            <ac:spMk id="11" creationId="{6A9C3E86-51AE-E415-AE46-871F1395CD67}"/>
           </ac:spMkLst>
         </pc:spChg>
-        <pc:picChg chg="del">
-          <ac:chgData name="Benjamín de Jesús Cueva Niño de Guzmán" userId="56da303013910523" providerId="LiveId" clId="{532B7A48-8887-4F62-9537-0BA1FAE83637}" dt="2026-01-14T23:39:27.620" v="13" actId="478"/>
-          <ac:picMkLst>
+        <pc:graphicFrameChg chg="mod modGraphic">
+          <ac:chgData name="Benjamín de Jesús Cueva Niño de Guzmán" userId="56da303013910523" providerId="LiveId" clId="{532B7A48-8887-4F62-9537-0BA1FAE83637}" dt="2026-03-02T03:10:22.602" v="56" actId="962"/>
+          <ac:graphicFrameMkLst>
             <pc:docMk/>
             <pc:sldMk cId="4084903007" sldId="278"/>
-            <ac:picMk id="7" creationId="{1A5F3F7F-F6EA-295F-A298-EE7118A8FF90}"/>
-          </ac:picMkLst>
-        </pc:picChg>
-        <pc:picChg chg="del">
-          <ac:chgData name="Benjamín de Jesús Cueva Niño de Guzmán" userId="56da303013910523" providerId="LiveId" clId="{532B7A48-8887-4F62-9537-0BA1FAE83637}" dt="2026-01-14T23:39:29.163" v="14" actId="478"/>
-          <ac:picMkLst>
-            <pc:docMk/>
-            <pc:sldMk cId="4084903007" sldId="278"/>
-            <ac:picMk id="17" creationId="{E2F7B553-0DD8-3254-E8A5-8AFCBCCE12B1}"/>
-          </ac:picMkLst>
-        </pc:picChg>
-        <pc:picChg chg="del">
-          <ac:chgData name="Benjamín de Jesús Cueva Niño de Guzmán" userId="56da303013910523" providerId="LiveId" clId="{532B7A48-8887-4F62-9537-0BA1FAE83637}" dt="2026-01-14T23:39:08.807" v="5" actId="478"/>
-          <ac:picMkLst>
-            <pc:docMk/>
-            <pc:sldMk cId="4084903007" sldId="278"/>
-            <ac:picMk id="26" creationId="{39C9745C-4A41-3AC5-CAAD-095724A20EBB}"/>
-          </ac:picMkLst>
-        </pc:picChg>
-      </pc:sldChg>
-      <pc:sldChg chg="del">
-        <pc:chgData name="Benjamín de Jesús Cueva Niño de Guzmán" userId="56da303013910523" providerId="LiveId" clId="{532B7A48-8887-4F62-9537-0BA1FAE83637}" dt="2026-01-14T23:38:56.402" v="2" actId="47"/>
-        <pc:sldMkLst>
-          <pc:docMk/>
-          <pc:sldMk cId="1379650257" sldId="279"/>
-        </pc:sldMkLst>
-      </pc:sldChg>
-      <pc:sldChg chg="del">
-        <pc:chgData name="Benjamín de Jesús Cueva Niño de Guzmán" userId="56da303013910523" providerId="LiveId" clId="{532B7A48-8887-4F62-9537-0BA1FAE83637}" dt="2026-01-14T23:38:56.766" v="3" actId="47"/>
-        <pc:sldMkLst>
-          <pc:docMk/>
-          <pc:sldMk cId="2353653050" sldId="280"/>
-        </pc:sldMkLst>
-      </pc:sldChg>
-      <pc:sldChg chg="del">
-        <pc:chgData name="Benjamín de Jesús Cueva Niño de Guzmán" userId="56da303013910523" providerId="LiveId" clId="{532B7A48-8887-4F62-9537-0BA1FAE83637}" dt="2026-01-14T23:38:55.858" v="0" actId="47"/>
-        <pc:sldMkLst>
-          <pc:docMk/>
-          <pc:sldMk cId="4178494260" sldId="281"/>
-        </pc:sldMkLst>
-      </pc:sldChg>
-      <pc:sldChg chg="del">
-        <pc:chgData name="Benjamín de Jesús Cueva Niño de Guzmán" userId="56da303013910523" providerId="LiveId" clId="{532B7A48-8887-4F62-9537-0BA1FAE83637}" dt="2026-01-14T23:38:56.003" v="1" actId="47"/>
-        <pc:sldMkLst>
-          <pc:docMk/>
-          <pc:sldMk cId="1741124028" sldId="282"/>
-        </pc:sldMkLst>
+            <ac:graphicFrameMk id="27" creationId="{E2902199-03EA-D12C-1A17-39EA239AECB5}"/>
+          </ac:graphicFrameMkLst>
+        </pc:graphicFrameChg>
       </pc:sldChg>
     </pc:docChg>
   </pc:docChgLst>
@@ -313,7 +285,7 @@
           <a:p>
             <a:fld id="{03C7FEFC-EB52-44D6-B3F1-2A7BB7FA4226}" type="datetimeFigureOut">
               <a:rPr lang="es-PE" smtClean="0"/>
-              <a:t>2/02/2026</a:t>
+              <a:t>1/03/2026</a:t>
             </a:fld>
             <a:endParaRPr lang="es-PE" dirty="0"/>
           </a:p>
@@ -478,7 +450,7 @@
           <a:p>
             <a:fld id="{64955E78-CBAA-441B-9163-D9CD5E983BDA}" type="datetimeFigureOut">
               <a:rPr lang="en-US" smtClean="0"/>
-              <a:t>2/2/2026</a:t>
+              <a:t>3/1/2026</a:t>
             </a:fld>
             <a:endParaRPr lang="en-US" dirty="0"/>
           </a:p>
@@ -877,7 +849,7 @@
           <a:p>
             <a:fld id="{5C4C4E00-4716-4B48-9D97-535E4F94A274}" type="datetimeFigureOut">
               <a:rPr lang="es-PE" smtClean="0"/>
-              <a:t>2/02/2026</a:t>
+              <a:t>1/03/2026</a:t>
             </a:fld>
             <a:endParaRPr lang="es-PE" dirty="0"/>
           </a:p>
@@ -1047,7 +1019,7 @@
           <a:p>
             <a:fld id="{5C4C4E00-4716-4B48-9D97-535E4F94A274}" type="datetimeFigureOut">
               <a:rPr lang="es-PE" smtClean="0"/>
-              <a:t>2/02/2026</a:t>
+              <a:t>1/03/2026</a:t>
             </a:fld>
             <a:endParaRPr lang="es-PE" dirty="0"/>
           </a:p>
@@ -1227,7 +1199,7 @@
           <a:p>
             <a:fld id="{5C4C4E00-4716-4B48-9D97-535E4F94A274}" type="datetimeFigureOut">
               <a:rPr lang="es-PE" smtClean="0"/>
-              <a:t>2/02/2026</a:t>
+              <a:t>1/03/2026</a:t>
             </a:fld>
             <a:endParaRPr lang="es-PE" dirty="0"/>
           </a:p>
@@ -1397,7 +1369,7 @@
           <a:p>
             <a:fld id="{5C4C4E00-4716-4B48-9D97-535E4F94A274}" type="datetimeFigureOut">
               <a:rPr lang="es-PE" smtClean="0"/>
-              <a:t>2/02/2026</a:t>
+              <a:t>1/03/2026</a:t>
             </a:fld>
             <a:endParaRPr lang="es-PE" dirty="0"/>
           </a:p>
@@ -1641,7 +1613,7 @@
           <a:p>
             <a:fld id="{5C4C4E00-4716-4B48-9D97-535E4F94A274}" type="datetimeFigureOut">
               <a:rPr lang="es-PE" smtClean="0"/>
-              <a:t>2/02/2026</a:t>
+              <a:t>1/03/2026</a:t>
             </a:fld>
             <a:endParaRPr lang="es-PE" dirty="0"/>
           </a:p>
@@ -1873,7 +1845,7 @@
           <a:p>
             <a:fld id="{5C4C4E00-4716-4B48-9D97-535E4F94A274}" type="datetimeFigureOut">
               <a:rPr lang="es-PE" smtClean="0"/>
-              <a:t>2/02/2026</a:t>
+              <a:t>1/03/2026</a:t>
             </a:fld>
             <a:endParaRPr lang="es-PE" dirty="0"/>
           </a:p>
@@ -2240,7 +2212,7 @@
           <a:p>
             <a:fld id="{5C4C4E00-4716-4B48-9D97-535E4F94A274}" type="datetimeFigureOut">
               <a:rPr lang="es-PE" smtClean="0"/>
-              <a:t>2/02/2026</a:t>
+              <a:t>1/03/2026</a:t>
             </a:fld>
             <a:endParaRPr lang="es-PE" dirty="0"/>
           </a:p>
@@ -2358,7 +2330,7 @@
           <a:p>
             <a:fld id="{5C4C4E00-4716-4B48-9D97-535E4F94A274}" type="datetimeFigureOut">
               <a:rPr lang="es-PE" smtClean="0"/>
-              <a:t>2/02/2026</a:t>
+              <a:t>1/03/2026</a:t>
             </a:fld>
             <a:endParaRPr lang="es-PE" dirty="0"/>
           </a:p>
@@ -2453,7 +2425,7 @@
           <a:p>
             <a:fld id="{5C4C4E00-4716-4B48-9D97-535E4F94A274}" type="datetimeFigureOut">
               <a:rPr lang="es-PE" smtClean="0"/>
-              <a:t>2/02/2026</a:t>
+              <a:t>1/03/2026</a:t>
             </a:fld>
             <a:endParaRPr lang="es-PE" dirty="0"/>
           </a:p>
@@ -2730,7 +2702,7 @@
           <a:p>
             <a:fld id="{5C4C4E00-4716-4B48-9D97-535E4F94A274}" type="datetimeFigureOut">
               <a:rPr lang="es-PE" smtClean="0"/>
-              <a:t>2/02/2026</a:t>
+              <a:t>1/03/2026</a:t>
             </a:fld>
             <a:endParaRPr lang="es-PE" dirty="0"/>
           </a:p>
@@ -2987,7 +2959,7 @@
           <a:p>
             <a:fld id="{5C4C4E00-4716-4B48-9D97-535E4F94A274}" type="datetimeFigureOut">
               <a:rPr lang="es-PE" smtClean="0"/>
-              <a:t>2/02/2026</a:t>
+              <a:t>1/03/2026</a:t>
             </a:fld>
             <a:endParaRPr lang="es-PE" dirty="0"/>
           </a:p>
@@ -3200,7 +3172,7 @@
           <a:p>
             <a:fld id="{5C4C4E00-4716-4B48-9D97-535E4F94A274}" type="datetimeFigureOut">
               <a:rPr lang="es-PE" smtClean="0"/>
-              <a:t>2/02/2026</a:t>
+              <a:t>1/03/2026</a:t>
             </a:fld>
             <a:endParaRPr lang="es-PE" dirty="0"/>
           </a:p>
@@ -3696,7 +3668,7 @@
         </p:nvSpPr>
         <p:spPr>
           <a:xfrm>
-            <a:off x="792012" y="2873820"/>
+            <a:off x="792012" y="2833479"/>
             <a:ext cx="5273976" cy="954107"/>
           </a:xfrm>
           <a:prstGeom prst="rect">
@@ -3958,43 +3930,277 @@
           </a:p>
         </p:txBody>
       </p:sp>
-      <p:sp>
-        <p:nvSpPr>
-          <p:cNvPr id="19" name="Rectangle 60">
+      <p:grpSp>
+        <p:nvGrpSpPr>
+          <p:cNvPr id="10" name="Grupo 9">
             <a:extLst>
               <a:ext uri="{FF2B5EF4-FFF2-40B4-BE49-F238E27FC236}">
-                <a16:creationId xmlns:a16="http://schemas.microsoft.com/office/drawing/2014/main" id="{991C4A27-894B-7257-8062-6F839343BAAD}"/>
+                <a16:creationId xmlns:a16="http://schemas.microsoft.com/office/drawing/2014/main" id="{4ED8877D-BD75-82CF-C5B8-EF26E5F3D309}"/>
               </a:ext>
             </a:extLst>
           </p:cNvPr>
-          <p:cNvSpPr/>
+          <p:cNvGrpSpPr/>
           <p:nvPr/>
-        </p:nvSpPr>
-        <p:spPr>
+        </p:nvGrpSpPr>
+        <p:grpSpPr>
           <a:xfrm>
-            <a:off x="570664" y="3680629"/>
-            <a:ext cx="5716673" cy="2967105"/>
+            <a:off x="570664" y="3761311"/>
+            <a:ext cx="5863899" cy="2973375"/>
+            <a:chOff x="570664" y="3761311"/>
+            <a:chExt cx="5863899" cy="2973375"/>
           </a:xfrm>
-          <a:prstGeom prst="rect">
-            <a:avLst/>
-          </a:prstGeom>
-          <a:ln>
-            <a:noFill/>
-          </a:ln>
-        </p:spPr>
-        <p:txBody>
-          <a:bodyPr vert="horz" lIns="0" tIns="0" rIns="0" bIns="0" rtlCol="0" anchor="ctr">
-            <a:noAutofit/>
-          </a:bodyPr>
-          <a:lstStyle/>
-          <a:p>
-            <a:pPr algn="ctr">
-              <a:spcBef>
-                <a:spcPts val="600"/>
-              </a:spcBef>
-            </a:pPr>
-            <a:r>
-              <a:rPr lang="es-PE" sz="1400" dirty="0">
+        </p:grpSpPr>
+        <p:sp>
+          <p:nvSpPr>
+            <p:cNvPr id="19" name="PH_CONTENIDO_PRINCIPAL">
+              <a:extLst>
+                <a:ext uri="{FF2B5EF4-FFF2-40B4-BE49-F238E27FC236}">
+                  <a16:creationId xmlns:a16="http://schemas.microsoft.com/office/drawing/2014/main" id="{991C4A27-894B-7257-8062-6F839343BAAD}"/>
+                </a:ext>
+              </a:extLst>
+            </p:cNvPr>
+            <p:cNvSpPr/>
+            <p:nvPr/>
+          </p:nvSpPr>
+          <p:spPr>
+            <a:xfrm>
+              <a:off x="570664" y="3761311"/>
+              <a:ext cx="5716673" cy="2600712"/>
+            </a:xfrm>
+            <a:prstGeom prst="rect">
+              <a:avLst/>
+            </a:prstGeom>
+            <a:ln>
+              <a:noFill/>
+            </a:ln>
+          </p:spPr>
+          <p:txBody>
+            <a:bodyPr vert="horz" lIns="0" tIns="0" rIns="0" bIns="0" rtlCol="0" anchor="t" anchorCtr="1">
+              <a:spAutoFit/>
+            </a:bodyPr>
+            <a:lstStyle/>
+            <a:p>
+              <a:pPr algn="ctr">
+                <a:spcBef>
+                  <a:spcPts val="600"/>
+                </a:spcBef>
+              </a:pPr>
+              <a:r>
+                <a:rPr lang="es-PE" sz="1400" dirty="0">
+                  <a:solidFill>
+                    <a:srgbClr val="000000"/>
+                  </a:solidFill>
+                  <a:effectLst/>
+                  <a:latin typeface="Times New Roman" panose="02020603050405020304" pitchFamily="18" charset="0"/>
+                  <a:ea typeface="Times New Roman" panose="02020603050405020304" pitchFamily="18" charset="0"/>
+                  <a:cs typeface="Times New Roman" panose="02020603050405020304" pitchFamily="18" charset="0"/>
+                </a:rPr>
+                <a:t>Por haber culminado satisfactoriamente el </a:t>
+              </a:r>
+              <a:r>
+                <a:rPr lang="es-PE" sz="1400" dirty="0">
+                  <a:solidFill>
+                    <a:srgbClr val="000000"/>
+                  </a:solidFill>
+                  <a:latin typeface="Times New Roman" panose="02020603050405020304" pitchFamily="18" charset="0"/>
+                  <a:ea typeface="Times New Roman" panose="02020603050405020304" pitchFamily="18" charset="0"/>
+                  <a:cs typeface="Times New Roman" panose="02020603050405020304" pitchFamily="18" charset="0"/>
+                </a:rPr>
+                <a:t>CURSO </a:t>
+              </a:r>
+              <a:r>
+                <a:rPr lang="es-PE" sz="1400" dirty="0">
+                  <a:solidFill>
+                    <a:srgbClr val="000000"/>
+                  </a:solidFill>
+                  <a:effectLst/>
+                  <a:latin typeface="Times New Roman" panose="02020603050405020304" pitchFamily="18" charset="0"/>
+                  <a:ea typeface="Times New Roman" panose="02020603050405020304" pitchFamily="18" charset="0"/>
+                  <a:cs typeface="Times New Roman" panose="02020603050405020304" pitchFamily="18" charset="0"/>
+                </a:rPr>
+                <a:t>en:</a:t>
+              </a:r>
+            </a:p>
+            <a:p>
+              <a:pPr algn="ctr">
+                <a:spcBef>
+                  <a:spcPts val="600"/>
+                </a:spcBef>
+              </a:pPr>
+              <a:r>
+                <a:rPr lang="es-PE" sz="2800" dirty="0">
+                  <a:solidFill>
+                    <a:schemeClr val="tx2">
+                      <a:lumMod val="50000"/>
+                    </a:schemeClr>
+                  </a:solidFill>
+                  <a:latin typeface="Britannic Bold" panose="020B0903060703020204" pitchFamily="34" charset="0"/>
+                  <a:ea typeface="Times New Roman" panose="02020603050405020304" pitchFamily="18" charset="0"/>
+                  <a:cs typeface="Simplified Arabic" panose="02020603050405020304" pitchFamily="18" charset="-78"/>
+                </a:rPr>
+                <a:t>“{{TEMA_DIPLOMADO}}</a:t>
+              </a:r>
+              <a:r>
+                <a:rPr lang="es-PE" sz="2800" dirty="0">
+                  <a:solidFill>
+                    <a:schemeClr val="tx2">
+                      <a:lumMod val="50000"/>
+                    </a:schemeClr>
+                  </a:solidFill>
+                  <a:effectLst/>
+                  <a:latin typeface="Britannic Bold" panose="020B0903060703020204" pitchFamily="34" charset="0"/>
+                  <a:ea typeface="Times New Roman" panose="02020603050405020304" pitchFamily="18" charset="0"/>
+                  <a:cs typeface="Simplified Arabic" panose="02020603050405020304" pitchFamily="18" charset="-78"/>
+                </a:rPr>
+                <a:t>”</a:t>
+              </a:r>
+            </a:p>
+            <a:p>
+              <a:pPr algn="ctr">
+                <a:spcBef>
+                  <a:spcPts val="600"/>
+                </a:spcBef>
+              </a:pPr>
+              <a:r>
+                <a:rPr lang="es-PE" sz="1400" dirty="0">
+                  <a:solidFill>
+                    <a:srgbClr val="000000"/>
+                  </a:solidFill>
+                  <a:effectLst/>
+                  <a:latin typeface="Arial" panose="020B0604020202020204" pitchFamily="34" charset="0"/>
+                  <a:ea typeface="Times New Roman" panose="02020603050405020304" pitchFamily="18" charset="0"/>
+                  <a:cs typeface="Arial" panose="020B0604020202020204" pitchFamily="34" charset="0"/>
+                </a:rPr>
+                <a:t> </a:t>
+              </a:r>
+              <a:r>
+                <a:rPr lang="es-PE" sz="1400" dirty="0">
+                  <a:solidFill>
+                    <a:srgbClr val="000000"/>
+                  </a:solidFill>
+                  <a:effectLst/>
+                  <a:latin typeface="Times New Roman" panose="02020603050405020304" pitchFamily="18" charset="0"/>
+                  <a:ea typeface="Times New Roman" panose="02020603050405020304" pitchFamily="18" charset="0"/>
+                  <a:cs typeface="Times New Roman" panose="02020603050405020304" pitchFamily="18" charset="0"/>
+                </a:rPr>
+                <a:t>Realizado por el Instituto Peruano de Diplomados y Especializaciones, que mantuvo participación acad</a:t>
+              </a:r>
+              <a:r>
+                <a:rPr lang="es-PE" sz="1400" dirty="0">
+                  <a:solidFill>
+                    <a:srgbClr val="000000"/>
+                  </a:solidFill>
+                  <a:latin typeface="Times New Roman" panose="02020603050405020304" pitchFamily="18" charset="0"/>
+                  <a:ea typeface="Times New Roman" panose="02020603050405020304" pitchFamily="18" charset="0"/>
+                  <a:cs typeface="Times New Roman" panose="02020603050405020304" pitchFamily="18" charset="0"/>
+                </a:rPr>
+                <a:t>émica con la Escuela de Posgrado de la Universidad Nacional de Trujillo</a:t>
+              </a:r>
+              <a:r>
+                <a:rPr lang="es-PE" sz="1400" dirty="0">
+                  <a:solidFill>
+                    <a:srgbClr val="000000"/>
+                  </a:solidFill>
+                  <a:effectLst/>
+                  <a:latin typeface="Times New Roman" panose="02020603050405020304" pitchFamily="18" charset="0"/>
+                  <a:ea typeface="Times New Roman" panose="02020603050405020304" pitchFamily="18" charset="0"/>
+                  <a:cs typeface="Times New Roman" panose="02020603050405020304" pitchFamily="18" charset="0"/>
+                </a:rPr>
+                <a:t>, según Resolución </a:t>
+              </a:r>
+              <a:r>
+                <a:rPr lang="es-PE" sz="1400" dirty="0">
+                  <a:solidFill>
+                    <a:srgbClr val="000000"/>
+                  </a:solidFill>
+                  <a:latin typeface="Times New Roman" panose="02020603050405020304" pitchFamily="18" charset="0"/>
+                  <a:ea typeface="Times New Roman" panose="02020603050405020304" pitchFamily="18" charset="0"/>
+                  <a:cs typeface="Times New Roman" panose="02020603050405020304" pitchFamily="18" charset="0"/>
+                </a:rPr>
+                <a:t>Directoral </a:t>
+              </a:r>
+              <a:r>
+                <a:rPr lang="es-PE" sz="1400" dirty="0">
+                  <a:solidFill>
+                    <a:srgbClr val="000000"/>
+                  </a:solidFill>
+                  <a:effectLst/>
+                  <a:latin typeface="Times New Roman" panose="02020603050405020304" pitchFamily="18" charset="0"/>
+                  <a:ea typeface="Times New Roman" panose="02020603050405020304" pitchFamily="18" charset="0"/>
+                  <a:cs typeface="Times New Roman" panose="02020603050405020304" pitchFamily="18" charset="0"/>
+                </a:rPr>
+                <a:t>N° </a:t>
+              </a:r>
+              <a:r>
+                <a:rPr lang="es-PE" sz="1400" dirty="0">
+                  <a:solidFill>
+                    <a:srgbClr val="000000"/>
+                  </a:solidFill>
+                  <a:latin typeface="Times New Roman" panose="02020603050405020304" pitchFamily="18" charset="0"/>
+                  <a:ea typeface="Times New Roman" panose="02020603050405020304" pitchFamily="18" charset="0"/>
+                  <a:cs typeface="Times New Roman" panose="02020603050405020304" pitchFamily="18" charset="0"/>
+                </a:rPr>
+                <a:t>2477</a:t>
+              </a:r>
+              <a:r>
+                <a:rPr lang="es-PE" sz="1400" dirty="0">
+                  <a:solidFill>
+                    <a:srgbClr val="000000"/>
+                  </a:solidFill>
+                  <a:effectLst/>
+                  <a:latin typeface="Times New Roman" panose="02020603050405020304" pitchFamily="18" charset="0"/>
+                  <a:ea typeface="Times New Roman" panose="02020603050405020304" pitchFamily="18" charset="0"/>
+                  <a:cs typeface="Times New Roman" panose="02020603050405020304" pitchFamily="18" charset="0"/>
+                </a:rPr>
+                <a:t>-2018-EPG/UNT</a:t>
+              </a:r>
+              <a:r>
+                <a:rPr lang="es-PE" sz="1400" dirty="0">
+                  <a:solidFill>
+                    <a:srgbClr val="000000"/>
+                  </a:solidFill>
+                  <a:latin typeface="Times New Roman" panose="02020603050405020304" pitchFamily="18" charset="0"/>
+                  <a:ea typeface="Times New Roman" panose="02020603050405020304" pitchFamily="18" charset="0"/>
+                  <a:cs typeface="Times New Roman" panose="02020603050405020304" pitchFamily="18" charset="0"/>
+                </a:rPr>
+                <a:t>. R</a:t>
+              </a:r>
+              <a:r>
+                <a:rPr lang="es-PE" sz="1400" dirty="0">
+                  <a:solidFill>
+                    <a:srgbClr val="000000"/>
+                  </a:solidFill>
+                  <a:effectLst/>
+                  <a:latin typeface="Times New Roman" panose="02020603050405020304" pitchFamily="18" charset="0"/>
+                  <a:ea typeface="Times New Roman" panose="02020603050405020304" pitchFamily="18" charset="0"/>
+                  <a:cs typeface="Times New Roman" panose="02020603050405020304" pitchFamily="18" charset="0"/>
+                </a:rPr>
+                <a:t>ealizado </a:t>
+              </a:r>
+              <a:r>
+                <a:rPr lang="es-PE" sz="1400" dirty="0">
+                  <a:solidFill>
+                    <a:srgbClr val="000000"/>
+                  </a:solidFill>
+                  <a:latin typeface="Times New Roman" panose="02020603050405020304" pitchFamily="18" charset="0"/>
+                  <a:ea typeface="Times New Roman" panose="02020603050405020304" pitchFamily="18" charset="0"/>
+                  <a:cs typeface="Times New Roman" panose="02020603050405020304" pitchFamily="18" charset="0"/>
+                </a:rPr>
+                <a:t>del {{FECHA_INICIO}} al {{FECHA_FIN}}</a:t>
+              </a:r>
+              <a:r>
+                <a:rPr lang="es-PE" sz="1400" dirty="0">
+                  <a:solidFill>
+                    <a:srgbClr val="000000"/>
+                  </a:solidFill>
+                  <a:effectLst/>
+                  <a:latin typeface="Times New Roman" panose="02020603050405020304" pitchFamily="18" charset="0"/>
+                  <a:ea typeface="Times New Roman" panose="02020603050405020304" pitchFamily="18" charset="0"/>
+                  <a:cs typeface="Times New Roman" panose="02020603050405020304" pitchFamily="18" charset="0"/>
+                </a:rPr>
+                <a:t>, con una duración de {{HORAS_ACADEMICAS}} horas académicas, equivalente a {{CREDITOS_ACADEMICOS}} créditos académicos.</a:t>
+              </a:r>
+              <a:endParaRPr lang="es-PE" sz="800" dirty="0">
                 <a:solidFill>
                   <a:srgbClr val="000000"/>
                 </a:solidFill>
@@ -4002,296 +4208,83 @@
                 <a:latin typeface="Times New Roman" panose="02020603050405020304" pitchFamily="18" charset="0"/>
                 <a:ea typeface="Times New Roman" panose="02020603050405020304" pitchFamily="18" charset="0"/>
                 <a:cs typeface="Times New Roman" panose="02020603050405020304" pitchFamily="18" charset="0"/>
-              </a:rPr>
-              <a:t>Por haber culminado satisfactoriamente el </a:t>
-            </a:r>
-            <a:r>
-              <a:rPr lang="es-PE" sz="1400" dirty="0">
-                <a:solidFill>
-                  <a:srgbClr val="000000"/>
-                </a:solidFill>
-                <a:latin typeface="Times New Roman" panose="02020603050405020304" pitchFamily="18" charset="0"/>
-                <a:ea typeface="Times New Roman" panose="02020603050405020304" pitchFamily="18" charset="0"/>
-                <a:cs typeface="Times New Roman" panose="02020603050405020304" pitchFamily="18" charset="0"/>
-              </a:rPr>
-              <a:t>CURSO </a:t>
-            </a:r>
-            <a:r>
-              <a:rPr lang="es-PE" sz="1400" dirty="0">
-                <a:solidFill>
-                  <a:srgbClr val="000000"/>
-                </a:solidFill>
-                <a:effectLst/>
-                <a:latin typeface="Times New Roman" panose="02020603050405020304" pitchFamily="18" charset="0"/>
-                <a:ea typeface="Times New Roman" panose="02020603050405020304" pitchFamily="18" charset="0"/>
-                <a:cs typeface="Times New Roman" panose="02020603050405020304" pitchFamily="18" charset="0"/>
-              </a:rPr>
-              <a:t>en:</a:t>
-            </a:r>
-          </a:p>
-          <a:p>
-            <a:pPr algn="ctr">
-              <a:spcBef>
-                <a:spcPts val="600"/>
-              </a:spcBef>
-            </a:pPr>
-            <a:r>
-              <a:rPr lang="es-PE" sz="2800" dirty="0">
-                <a:solidFill>
-                  <a:schemeClr val="tx2">
-                    <a:lumMod val="50000"/>
-                  </a:schemeClr>
-                </a:solidFill>
-                <a:latin typeface="Britannic Bold" panose="020B0903060703020204" pitchFamily="34" charset="0"/>
-                <a:ea typeface="Times New Roman" panose="02020603050405020304" pitchFamily="18" charset="0"/>
-                <a:cs typeface="Simplified Arabic" panose="02020603050405020304" pitchFamily="18" charset="-78"/>
-              </a:rPr>
-              <a:t>“{{TEMA_DIPLOMADO}}</a:t>
-            </a:r>
-            <a:r>
-              <a:rPr lang="es-PE" sz="2800" dirty="0">
-                <a:solidFill>
-                  <a:schemeClr val="tx2">
-                    <a:lumMod val="50000"/>
-                  </a:schemeClr>
-                </a:solidFill>
-                <a:effectLst/>
-                <a:latin typeface="Britannic Bold" panose="020B0903060703020204" pitchFamily="34" charset="0"/>
-                <a:ea typeface="Times New Roman" panose="02020603050405020304" pitchFamily="18" charset="0"/>
-                <a:cs typeface="Simplified Arabic" panose="02020603050405020304" pitchFamily="18" charset="-78"/>
-              </a:rPr>
-              <a:t>”</a:t>
-            </a:r>
-          </a:p>
-          <a:p>
-            <a:pPr algn="ctr">
-              <a:spcBef>
-                <a:spcPts val="600"/>
-              </a:spcBef>
-            </a:pPr>
-            <a:r>
-              <a:rPr lang="es-PE" sz="1400" dirty="0">
-                <a:solidFill>
-                  <a:srgbClr val="000000"/>
-                </a:solidFill>
-                <a:effectLst/>
-                <a:latin typeface="Arial" panose="020B0604020202020204" pitchFamily="34" charset="0"/>
-                <a:ea typeface="Times New Roman" panose="02020603050405020304" pitchFamily="18" charset="0"/>
-                <a:cs typeface="Arial" panose="020B0604020202020204" pitchFamily="34" charset="0"/>
-              </a:rPr>
-              <a:t> </a:t>
-            </a:r>
-            <a:r>
-              <a:rPr lang="es-PE" sz="1400" dirty="0">
-                <a:solidFill>
-                  <a:srgbClr val="000000"/>
-                </a:solidFill>
-                <a:effectLst/>
-                <a:latin typeface="Times New Roman" panose="02020603050405020304" pitchFamily="18" charset="0"/>
-                <a:ea typeface="Times New Roman" panose="02020603050405020304" pitchFamily="18" charset="0"/>
-                <a:cs typeface="Times New Roman" panose="02020603050405020304" pitchFamily="18" charset="0"/>
-              </a:rPr>
-              <a:t>Realizado por el Instituto Peruano de Diplomados y Especializaciones, que mantuvo participación acad</a:t>
-            </a:r>
-            <a:r>
-              <a:rPr lang="es-PE" sz="1400" dirty="0">
-                <a:solidFill>
-                  <a:srgbClr val="000000"/>
-                </a:solidFill>
-                <a:latin typeface="Times New Roman" panose="02020603050405020304" pitchFamily="18" charset="0"/>
-                <a:ea typeface="Times New Roman" panose="02020603050405020304" pitchFamily="18" charset="0"/>
-                <a:cs typeface="Times New Roman" panose="02020603050405020304" pitchFamily="18" charset="0"/>
-              </a:rPr>
-              <a:t>émica con la Escuela de Posgrado de la Universidad Nacional de Trujillo</a:t>
-            </a:r>
-            <a:r>
-              <a:rPr lang="es-PE" sz="1400" dirty="0">
-                <a:solidFill>
-                  <a:srgbClr val="000000"/>
-                </a:solidFill>
-                <a:effectLst/>
-                <a:latin typeface="Times New Roman" panose="02020603050405020304" pitchFamily="18" charset="0"/>
-                <a:ea typeface="Times New Roman" panose="02020603050405020304" pitchFamily="18" charset="0"/>
-                <a:cs typeface="Times New Roman" panose="02020603050405020304" pitchFamily="18" charset="0"/>
-              </a:rPr>
-              <a:t>, según Resolución </a:t>
-            </a:r>
-            <a:r>
-              <a:rPr lang="es-PE" sz="1400" dirty="0">
-                <a:solidFill>
-                  <a:srgbClr val="000000"/>
-                </a:solidFill>
-                <a:latin typeface="Times New Roman" panose="02020603050405020304" pitchFamily="18" charset="0"/>
-                <a:ea typeface="Times New Roman" panose="02020603050405020304" pitchFamily="18" charset="0"/>
-                <a:cs typeface="Times New Roman" panose="02020603050405020304" pitchFamily="18" charset="0"/>
-              </a:rPr>
-              <a:t>Directoral </a:t>
-            </a:r>
-            <a:r>
-              <a:rPr lang="es-PE" sz="1400" dirty="0">
-                <a:solidFill>
-                  <a:srgbClr val="000000"/>
-                </a:solidFill>
-                <a:effectLst/>
-                <a:latin typeface="Times New Roman" panose="02020603050405020304" pitchFamily="18" charset="0"/>
-                <a:ea typeface="Times New Roman" panose="02020603050405020304" pitchFamily="18" charset="0"/>
-                <a:cs typeface="Times New Roman" panose="02020603050405020304" pitchFamily="18" charset="0"/>
-              </a:rPr>
-              <a:t>N° </a:t>
-            </a:r>
-            <a:r>
-              <a:rPr lang="es-PE" sz="1400" dirty="0">
-                <a:solidFill>
-                  <a:srgbClr val="000000"/>
-                </a:solidFill>
-                <a:latin typeface="Times New Roman" panose="02020603050405020304" pitchFamily="18" charset="0"/>
-                <a:ea typeface="Times New Roman" panose="02020603050405020304" pitchFamily="18" charset="0"/>
-                <a:cs typeface="Times New Roman" panose="02020603050405020304" pitchFamily="18" charset="0"/>
-              </a:rPr>
-              <a:t>2477</a:t>
-            </a:r>
-            <a:r>
-              <a:rPr lang="es-PE" sz="1400" dirty="0">
-                <a:solidFill>
-                  <a:srgbClr val="000000"/>
-                </a:solidFill>
-                <a:effectLst/>
-                <a:latin typeface="Times New Roman" panose="02020603050405020304" pitchFamily="18" charset="0"/>
-                <a:ea typeface="Times New Roman" panose="02020603050405020304" pitchFamily="18" charset="0"/>
-                <a:cs typeface="Times New Roman" panose="02020603050405020304" pitchFamily="18" charset="0"/>
-              </a:rPr>
-              <a:t>-2018-EPG/UNT</a:t>
-            </a:r>
-            <a:r>
-              <a:rPr lang="es-PE" sz="1400" dirty="0">
-                <a:solidFill>
-                  <a:srgbClr val="000000"/>
-                </a:solidFill>
-                <a:latin typeface="Times New Roman" panose="02020603050405020304" pitchFamily="18" charset="0"/>
-                <a:ea typeface="Times New Roman" panose="02020603050405020304" pitchFamily="18" charset="0"/>
-                <a:cs typeface="Times New Roman" panose="02020603050405020304" pitchFamily="18" charset="0"/>
-              </a:rPr>
-              <a:t>. R</a:t>
-            </a:r>
-            <a:r>
-              <a:rPr lang="es-PE" sz="1400" dirty="0">
-                <a:solidFill>
-                  <a:srgbClr val="000000"/>
-                </a:solidFill>
-                <a:effectLst/>
-                <a:latin typeface="Times New Roman" panose="02020603050405020304" pitchFamily="18" charset="0"/>
-                <a:ea typeface="Times New Roman" panose="02020603050405020304" pitchFamily="18" charset="0"/>
-                <a:cs typeface="Times New Roman" panose="02020603050405020304" pitchFamily="18" charset="0"/>
-              </a:rPr>
-              <a:t>ealizado </a:t>
-            </a:r>
-            <a:r>
-              <a:rPr lang="es-PE" sz="1400" dirty="0">
-                <a:solidFill>
-                  <a:srgbClr val="000000"/>
-                </a:solidFill>
-                <a:latin typeface="Times New Roman" panose="02020603050405020304" pitchFamily="18" charset="0"/>
-                <a:ea typeface="Times New Roman" panose="02020603050405020304" pitchFamily="18" charset="0"/>
-                <a:cs typeface="Times New Roman" panose="02020603050405020304" pitchFamily="18" charset="0"/>
-              </a:rPr>
-              <a:t>del {{FECHA_INICIO}} al {{FECHA_FIN}}</a:t>
-            </a:r>
-            <a:r>
-              <a:rPr lang="es-PE" sz="1400" dirty="0">
-                <a:solidFill>
-                  <a:srgbClr val="000000"/>
-                </a:solidFill>
-                <a:effectLst/>
-                <a:latin typeface="Times New Roman" panose="02020603050405020304" pitchFamily="18" charset="0"/>
-                <a:ea typeface="Times New Roman" panose="02020603050405020304" pitchFamily="18" charset="0"/>
-                <a:cs typeface="Times New Roman" panose="02020603050405020304" pitchFamily="18" charset="0"/>
-              </a:rPr>
-              <a:t>, con una duración de {{HORAS_ACADEMICAS}} horas académicas, equivalente a {{CREDITOS_ACADEMICOS}} créditos académicos.</a:t>
-            </a:r>
-            <a:endParaRPr lang="es-PE" sz="800" dirty="0">
-              <a:solidFill>
-                <a:srgbClr val="000000"/>
-              </a:solidFill>
-              <a:effectLst/>
-              <a:latin typeface="Times New Roman" panose="02020603050405020304" pitchFamily="18" charset="0"/>
-              <a:ea typeface="Times New Roman" panose="02020603050405020304" pitchFamily="18" charset="0"/>
-              <a:cs typeface="Times New Roman" panose="02020603050405020304" pitchFamily="18" charset="0"/>
-            </a:endParaRPr>
-          </a:p>
-          <a:p>
-            <a:pPr algn="ctr">
-              <a:spcBef>
-                <a:spcPts val="600"/>
-              </a:spcBef>
-            </a:pPr>
-            <a:r>
-              <a:rPr lang="es-PE" sz="1400" dirty="0">
-                <a:latin typeface="Times New Roman" panose="02020603050405020304" pitchFamily="18" charset="0"/>
-                <a:ea typeface="Cambria Math" panose="02040503050406030204" pitchFamily="18" charset="0"/>
-                <a:cs typeface="Times New Roman" panose="02020603050405020304" pitchFamily="18" charset="0"/>
-              </a:rPr>
-              <a:t>Por tanto, se expide el presente Certificado otorgándole los privilegios y consideraciones que le corresponden.</a:t>
-            </a:r>
-          </a:p>
-        </p:txBody>
-      </p:sp>
-      <p:sp>
-        <p:nvSpPr>
-          <p:cNvPr id="7" name="Rectángulo 6">
-            <a:extLst>
-              <a:ext uri="{FF2B5EF4-FFF2-40B4-BE49-F238E27FC236}">
-                <a16:creationId xmlns:a16="http://schemas.microsoft.com/office/drawing/2014/main" id="{F36D8880-B179-580E-0319-C4E9487E072A}"/>
-              </a:ext>
-            </a:extLst>
-          </p:cNvPr>
-          <p:cNvSpPr/>
-          <p:nvPr/>
-        </p:nvSpPr>
-        <p:spPr>
-          <a:xfrm>
-            <a:off x="3075083" y="6831263"/>
-            <a:ext cx="3359480" cy="320280"/>
-          </a:xfrm>
-          <a:prstGeom prst="rect">
-            <a:avLst/>
-          </a:prstGeom>
-        </p:spPr>
-        <p:txBody>
-          <a:bodyPr wrap="square">
-            <a:spAutoFit/>
-          </a:bodyPr>
-          <a:lstStyle/>
-          <a:p>
-            <a:pPr lvl="0" algn="r">
-              <a:lnSpc>
-                <a:spcPct val="115000"/>
-              </a:lnSpc>
-              <a:spcBef>
-                <a:spcPts val="59"/>
-              </a:spcBef>
-            </a:pPr>
-            <a:r>
-              <a:rPr lang="es-PE" sz="1400" dirty="0">
+              </a:endParaRPr>
+            </a:p>
+            <a:p>
+              <a:pPr algn="ctr">
+                <a:spcBef>
+                  <a:spcPts val="600"/>
+                </a:spcBef>
+              </a:pPr>
+              <a:r>
+                <a:rPr lang="es-PE" sz="1400" dirty="0">
+                  <a:latin typeface="Times New Roman" panose="02020603050405020304" pitchFamily="18" charset="0"/>
+                  <a:ea typeface="Cambria Math" panose="02040503050406030204" pitchFamily="18" charset="0"/>
+                  <a:cs typeface="Times New Roman" panose="02020603050405020304" pitchFamily="18" charset="0"/>
+                </a:rPr>
+                <a:t>Por tanto, se expide el presente Certificado otorgándole los privilegios y consideraciones que le corresponden.</a:t>
+              </a:r>
+            </a:p>
+          </p:txBody>
+        </p:sp>
+        <p:sp>
+          <p:nvSpPr>
+            <p:cNvPr id="7" name="Rectángulo 6">
+              <a:extLst>
+                <a:ext uri="{FF2B5EF4-FFF2-40B4-BE49-F238E27FC236}">
+                  <a16:creationId xmlns:a16="http://schemas.microsoft.com/office/drawing/2014/main" id="{F36D8880-B179-580E-0319-C4E9487E072A}"/>
+                </a:ext>
+              </a:extLst>
+            </p:cNvPr>
+            <p:cNvSpPr/>
+            <p:nvPr/>
+          </p:nvSpPr>
+          <p:spPr>
+            <a:xfrm>
+              <a:off x="3075083" y="6414406"/>
+              <a:ext cx="3359480" cy="320280"/>
+            </a:xfrm>
+            <a:prstGeom prst="rect">
+              <a:avLst/>
+            </a:prstGeom>
+          </p:spPr>
+          <p:txBody>
+            <a:bodyPr wrap="square">
+              <a:spAutoFit/>
+            </a:bodyPr>
+            <a:lstStyle/>
+            <a:p>
+              <a:pPr lvl="0" algn="r">
+                <a:lnSpc>
+                  <a:spcPct val="115000"/>
+                </a:lnSpc>
+                <a:spcBef>
+                  <a:spcPts val="59"/>
+                </a:spcBef>
+              </a:pPr>
+              <a:r>
+                <a:rPr lang="es-PE" sz="1400" dirty="0">
+                  <a:solidFill>
+                    <a:prstClr val="black"/>
+                  </a:solidFill>
+                  <a:latin typeface="Times New Roman" panose="02020603050405020304" pitchFamily="18" charset="0"/>
+                  <a:ea typeface="Cambria Math" panose="02040503050406030204" pitchFamily="18" charset="0"/>
+                  <a:cs typeface="Times New Roman" panose="02020603050405020304" pitchFamily="18" charset="0"/>
+                </a:rPr>
+                <a:t>Trujillo, {{FECHA_EMISION_LARGA}}</a:t>
+              </a:r>
+              <a:endParaRPr lang="en-US" sz="1400" dirty="0">
                 <a:solidFill>
                   <a:prstClr val="black"/>
                 </a:solidFill>
                 <a:latin typeface="Times New Roman" panose="02020603050405020304" pitchFamily="18" charset="0"/>
                 <a:ea typeface="Cambria Math" panose="02040503050406030204" pitchFamily="18" charset="0"/>
                 <a:cs typeface="Times New Roman" panose="02020603050405020304" pitchFamily="18" charset="0"/>
-              </a:rPr>
-              <a:t>Trujillo, {{FECHA_EMISION_LARGA}}</a:t>
-            </a:r>
-            <a:endParaRPr lang="en-US" sz="1400" dirty="0">
-              <a:solidFill>
-                <a:prstClr val="black"/>
-              </a:solidFill>
-              <a:latin typeface="Times New Roman" panose="02020603050405020304" pitchFamily="18" charset="0"/>
-              <a:ea typeface="Cambria Math" panose="02040503050406030204" pitchFamily="18" charset="0"/>
-              <a:cs typeface="Times New Roman" panose="02020603050405020304" pitchFamily="18" charset="0"/>
-            </a:endParaRPr>
-          </a:p>
-        </p:txBody>
-      </p:sp>
+              </a:endParaRPr>
+            </a:p>
+          </p:txBody>
+        </p:sp>
+      </p:grpSp>
       <p:sp>
         <p:nvSpPr>
           <p:cNvPr id="20" name="Rectángulo 19">
@@ -5021,7 +5014,7 @@
       </p:pic>
       <p:sp>
         <p:nvSpPr>
-          <p:cNvPr id="11" name="CuadroTexto 10">
+          <p:cNvPr id="11" name="PH_TEMA">
             <a:extLst>
               <a:ext uri="{FF2B5EF4-FFF2-40B4-BE49-F238E27FC236}">
                 <a16:creationId xmlns:a16="http://schemas.microsoft.com/office/drawing/2014/main" id="{6A9C3E86-51AE-E415-AE46-871F1395CD67}"/>
@@ -5460,7 +5453,7 @@
       </p:sp>
       <p:graphicFrame>
         <p:nvGraphicFramePr>
-          <p:cNvPr id="27" name="Tabla 26">
+          <p:cNvPr id="27" name="PH_TABLA">
             <a:extLst>
               <a:ext uri="{FF2B5EF4-FFF2-40B4-BE49-F238E27FC236}">
                 <a16:creationId xmlns:a16="http://schemas.microsoft.com/office/drawing/2014/main" id="{E2902199-03EA-D12C-1A17-39EA239AECB5}"/>
@@ -5473,13 +5466,13 @@
           <p:nvPr>
             <p:extLst>
               <p:ext uri="{D42A27DB-BD31-4B8C-83A1-F6EECF244321}">
-                <p14:modId xmlns:p14="http://schemas.microsoft.com/office/powerpoint/2010/main" val="187188832"/>
+                <p14:modId xmlns:p14="http://schemas.microsoft.com/office/powerpoint/2010/main" val="2710888816"/>
               </p:ext>
             </p:extLst>
           </p:nvPr>
         </p:nvGraphicFramePr>
         <p:xfrm>
-          <a:off x="745017" y="2907852"/>
+          <a:off x="745017" y="2921299"/>
           <a:ext cx="5367967" cy="3475566"/>
         </p:xfrm>
         <a:graphic>
@@ -5658,7 +5651,7 @@
                     <a:p>
                       <a:pPr algn="ctr"/>
                       <a:r>
-                        <a:rPr lang="es-ES" sz="1050" dirty="0"/>
+                        <a:rPr lang="es-ES" sz="950" dirty="0"/>
                         <a:t>{{MODULO_1}}</a:t>
                       </a:r>
                     </a:p>
@@ -5751,7 +5744,7 @@
                         <a:defRPr/>
                       </a:pPr>
                       <a:r>
-                        <a:rPr lang="es-ES" sz="1050" dirty="0"/>
+                        <a:rPr lang="es-ES" sz="950" dirty="0"/>
                         <a:t>{{MODULO_2}}</a:t>
                       </a:r>
                     </a:p>
@@ -5828,7 +5821,7 @@
                         <a:defRPr/>
                       </a:pPr>
                       <a:r>
-                        <a:rPr lang="es-ES" sz="1050" dirty="0"/>
+                        <a:rPr lang="es-ES" sz="950" dirty="0"/>
                         <a:t>{{MODULO_3}}</a:t>
                       </a:r>
                     </a:p>
@@ -5921,10 +5914,10 @@
                         <a:defRPr/>
                       </a:pPr>
                       <a:r>
-                        <a:rPr lang="es-ES" sz="1050" dirty="0"/>
+                        <a:rPr lang="es-ES" sz="950" dirty="0"/>
                         <a:t>{{MODULO_4}}</a:t>
                       </a:r>
-                      <a:endParaRPr lang="es-ES" sz="1050" b="0" i="0" kern="1200" dirty="0">
+                      <a:endParaRPr lang="es-ES" sz="950" b="0" i="0" kern="1200" dirty="0">
                         <a:solidFill>
                           <a:schemeClr val="dk1"/>
                         </a:solidFill>
@@ -6023,7 +6016,7 @@
                         <a:defRPr/>
                       </a:pPr>
                       <a:r>
-                        <a:rPr lang="es-ES" sz="1050" dirty="0"/>
+                        <a:rPr lang="es-ES" sz="950" dirty="0"/>
                         <a:t>{{MODULO_5}}</a:t>
                       </a:r>
                     </a:p>

</xml_diff>